<commit_message>
Align pitch deck order and cues
</commit_message>
<xml_diff>
--- a/docs/hyperspace-frontier-pitch-video-deck.pptx
+++ b/docs/hyperspace-frontier-pitch-video-deck.pptx
@@ -1,6 +1,6 @@
 
 <file path=ppt/presentation.xml><?xml version="1.0" encoding="utf-8"?>
-<p:presentation xmlns:ns2="http://schemas.openxmlformats.org/drawingml/2006/main" xmlns:ns3="http://schemas.microsoft.com/office/powerpoint/2012/main" xmlns:p="http://schemas.openxmlformats.org/presentationml/2006/main" xmlns:r="http://schemas.openxmlformats.org/officeDocument/2006/relationships" embedTrueTypeFonts="1" saveSubsetFonts="1" autoCompressPictures="0">
+<p:presentation xmlns:a="http://schemas.openxmlformats.org/drawingml/2006/main" xmlns:p="http://schemas.openxmlformats.org/presentationml/2006/main" xmlns:p15="http://schemas.microsoft.com/office/powerpoint/2012/main" xmlns:r="http://schemas.openxmlformats.org/officeDocument/2006/relationships" embedTrueTypeFonts="1" saveSubsetFonts="1" autoCompressPictures="0">
   <p:sldMasterIdLst>
     <p:sldMasterId id="2147483648" r:id="rId1"/>
   </p:sldMasterIdLst>
@@ -9,16 +9,16 @@
   </p:notesMasterIdLst>
   <p:sldIdLst>
     <p:sldId id="256" r:id="rId2"/>
+    <p:sldId id="257" r:id="rId3"/>
+    <p:sldId id="258" r:id="rId4"/>
     <p:sldId id="259" r:id="rId5"/>
     <p:sldId id="260" r:id="rId6"/>
     <p:sldId id="261" r:id="rId7"/>
+    <p:sldId id="262" r:id="rId8"/>
     <p:sldId id="263" r:id="rId9"/>
     <p:sldId id="264" r:id="rId10"/>
+    <p:sldId id="266" r:id="rId12"/>
     <p:sldId id="265" r:id="rId11"/>
-    <p:sldId id="257" r:id="rId3"/>
-    <p:sldId id="258" r:id="rId4"/>
-    <p:sldId id="262" r:id="rId8"/>
-    <p:sldId id="266" r:id="rId12"/>
   </p:sldIdLst>
   <p:sldSz cx="9144000" cy="5143500" type="screen16x9"/>
   <p:notesSz cx="5143500" cy="9144000"/>
@@ -29,100 +29,100 @@
     </p:embeddedFont>
   </p:embeddedFontLst>
   <p:defaultTextStyle>
-    <ns2:lvl1pPr marL="0" algn="l" defTabSz="914400" rtl="0" eaLnBrk="1" latinLnBrk="0" hangingPunct="1">
-      <ns2:defRPr sz="1800" kern="1200">
-        <ns2:solidFill>
-          <ns2:schemeClr val="tx1"/>
-        </ns2:solidFill>
-        <ns2:latin typeface="+mn-lt"/>
-        <ns2:ea typeface="+mn-ea"/>
-        <ns2:cs typeface="+mn-cs"/>
-      </ns2:defRPr>
-    </ns2:lvl1pPr>
-    <ns2:lvl2pPr marL="457200" algn="l" defTabSz="914400" rtl="0" eaLnBrk="1" latinLnBrk="0" hangingPunct="1">
-      <ns2:defRPr sz="1800" kern="1200">
-        <ns2:solidFill>
-          <ns2:schemeClr val="tx1"/>
-        </ns2:solidFill>
-        <ns2:latin typeface="+mn-lt"/>
-        <ns2:ea typeface="+mn-ea"/>
-        <ns2:cs typeface="+mn-cs"/>
-      </ns2:defRPr>
-    </ns2:lvl2pPr>
-    <ns2:lvl3pPr marL="914400" algn="l" defTabSz="914400" rtl="0" eaLnBrk="1" latinLnBrk="0" hangingPunct="1">
-      <ns2:defRPr sz="1800" kern="1200">
-        <ns2:solidFill>
-          <ns2:schemeClr val="tx1"/>
-        </ns2:solidFill>
-        <ns2:latin typeface="+mn-lt"/>
-        <ns2:ea typeface="+mn-ea"/>
-        <ns2:cs typeface="+mn-cs"/>
-      </ns2:defRPr>
-    </ns2:lvl3pPr>
-    <ns2:lvl4pPr marL="1371600" algn="l" defTabSz="914400" rtl="0" eaLnBrk="1" latinLnBrk="0" hangingPunct="1">
-      <ns2:defRPr sz="1800" kern="1200">
-        <ns2:solidFill>
-          <ns2:schemeClr val="tx1"/>
-        </ns2:solidFill>
-        <ns2:latin typeface="+mn-lt"/>
-        <ns2:ea typeface="+mn-ea"/>
-        <ns2:cs typeface="+mn-cs"/>
-      </ns2:defRPr>
-    </ns2:lvl4pPr>
-    <ns2:lvl5pPr marL="1828800" algn="l" defTabSz="914400" rtl="0" eaLnBrk="1" latinLnBrk="0" hangingPunct="1">
-      <ns2:defRPr sz="1800" kern="1200">
-        <ns2:solidFill>
-          <ns2:schemeClr val="tx1"/>
-        </ns2:solidFill>
-        <ns2:latin typeface="+mn-lt"/>
-        <ns2:ea typeface="+mn-ea"/>
-        <ns2:cs typeface="+mn-cs"/>
-      </ns2:defRPr>
-    </ns2:lvl5pPr>
-    <ns2:lvl6pPr marL="2286000" algn="l" defTabSz="914400" rtl="0" eaLnBrk="1" latinLnBrk="0" hangingPunct="1">
-      <ns2:defRPr sz="1800" kern="1200">
-        <ns2:solidFill>
-          <ns2:schemeClr val="tx1"/>
-        </ns2:solidFill>
-        <ns2:latin typeface="+mn-lt"/>
-        <ns2:ea typeface="+mn-ea"/>
-        <ns2:cs typeface="+mn-cs"/>
-      </ns2:defRPr>
-    </ns2:lvl6pPr>
-    <ns2:lvl7pPr marL="2743200" algn="l" defTabSz="914400" rtl="0" eaLnBrk="1" latinLnBrk="0" hangingPunct="1">
-      <ns2:defRPr sz="1800" kern="1200">
-        <ns2:solidFill>
-          <ns2:schemeClr val="tx1"/>
-        </ns2:solidFill>
-        <ns2:latin typeface="+mn-lt"/>
-        <ns2:ea typeface="+mn-ea"/>
-        <ns2:cs typeface="+mn-cs"/>
-      </ns2:defRPr>
-    </ns2:lvl7pPr>
-    <ns2:lvl8pPr marL="3200400" algn="l" defTabSz="914400" rtl="0" eaLnBrk="1" latinLnBrk="0" hangingPunct="1">
-      <ns2:defRPr sz="1800" kern="1200">
-        <ns2:solidFill>
-          <ns2:schemeClr val="tx1"/>
-        </ns2:solidFill>
-        <ns2:latin typeface="+mn-lt"/>
-        <ns2:ea typeface="+mn-ea"/>
-        <ns2:cs typeface="+mn-cs"/>
-      </ns2:defRPr>
-    </ns2:lvl8pPr>
-    <ns2:lvl9pPr marL="3657600" algn="l" defTabSz="914400" rtl="0" eaLnBrk="1" latinLnBrk="0" hangingPunct="1">
-      <ns2:defRPr sz="1800" kern="1200">
-        <ns2:solidFill>
-          <ns2:schemeClr val="tx1"/>
-        </ns2:solidFill>
-        <ns2:latin typeface="+mn-lt"/>
-        <ns2:ea typeface="+mn-ea"/>
-        <ns2:cs typeface="+mn-cs"/>
-      </ns2:defRPr>
-    </ns2:lvl9pPr>
+    <a:lvl1pPr marL="0" algn="l" defTabSz="914400" rtl="0" eaLnBrk="1" latinLnBrk="0" hangingPunct="1">
+      <a:defRPr sz="1800" kern="1200">
+        <a:solidFill>
+          <a:schemeClr val="tx1"/>
+        </a:solidFill>
+        <a:latin typeface="+mn-lt"/>
+        <a:ea typeface="+mn-ea"/>
+        <a:cs typeface="+mn-cs"/>
+      </a:defRPr>
+    </a:lvl1pPr>
+    <a:lvl2pPr marL="457200" algn="l" defTabSz="914400" rtl="0" eaLnBrk="1" latinLnBrk="0" hangingPunct="1">
+      <a:defRPr sz="1800" kern="1200">
+        <a:solidFill>
+          <a:schemeClr val="tx1"/>
+        </a:solidFill>
+        <a:latin typeface="+mn-lt"/>
+        <a:ea typeface="+mn-ea"/>
+        <a:cs typeface="+mn-cs"/>
+      </a:defRPr>
+    </a:lvl2pPr>
+    <a:lvl3pPr marL="914400" algn="l" defTabSz="914400" rtl="0" eaLnBrk="1" latinLnBrk="0" hangingPunct="1">
+      <a:defRPr sz="1800" kern="1200">
+        <a:solidFill>
+          <a:schemeClr val="tx1"/>
+        </a:solidFill>
+        <a:latin typeface="+mn-lt"/>
+        <a:ea typeface="+mn-ea"/>
+        <a:cs typeface="+mn-cs"/>
+      </a:defRPr>
+    </a:lvl3pPr>
+    <a:lvl4pPr marL="1371600" algn="l" defTabSz="914400" rtl="0" eaLnBrk="1" latinLnBrk="0" hangingPunct="1">
+      <a:defRPr sz="1800" kern="1200">
+        <a:solidFill>
+          <a:schemeClr val="tx1"/>
+        </a:solidFill>
+        <a:latin typeface="+mn-lt"/>
+        <a:ea typeface="+mn-ea"/>
+        <a:cs typeface="+mn-cs"/>
+      </a:defRPr>
+    </a:lvl4pPr>
+    <a:lvl5pPr marL="1828800" algn="l" defTabSz="914400" rtl="0" eaLnBrk="1" latinLnBrk="0" hangingPunct="1">
+      <a:defRPr sz="1800" kern="1200">
+        <a:solidFill>
+          <a:schemeClr val="tx1"/>
+        </a:solidFill>
+        <a:latin typeface="+mn-lt"/>
+        <a:ea typeface="+mn-ea"/>
+        <a:cs typeface="+mn-cs"/>
+      </a:defRPr>
+    </a:lvl5pPr>
+    <a:lvl6pPr marL="2286000" algn="l" defTabSz="914400" rtl="0" eaLnBrk="1" latinLnBrk="0" hangingPunct="1">
+      <a:defRPr sz="1800" kern="1200">
+        <a:solidFill>
+          <a:schemeClr val="tx1"/>
+        </a:solidFill>
+        <a:latin typeface="+mn-lt"/>
+        <a:ea typeface="+mn-ea"/>
+        <a:cs typeface="+mn-cs"/>
+      </a:defRPr>
+    </a:lvl6pPr>
+    <a:lvl7pPr marL="2743200" algn="l" defTabSz="914400" rtl="0" eaLnBrk="1" latinLnBrk="0" hangingPunct="1">
+      <a:defRPr sz="1800" kern="1200">
+        <a:solidFill>
+          <a:schemeClr val="tx1"/>
+        </a:solidFill>
+        <a:latin typeface="+mn-lt"/>
+        <a:ea typeface="+mn-ea"/>
+        <a:cs typeface="+mn-cs"/>
+      </a:defRPr>
+    </a:lvl7pPr>
+    <a:lvl8pPr marL="3200400" algn="l" defTabSz="914400" rtl="0" eaLnBrk="1" latinLnBrk="0" hangingPunct="1">
+      <a:defRPr sz="1800" kern="1200">
+        <a:solidFill>
+          <a:schemeClr val="tx1"/>
+        </a:solidFill>
+        <a:latin typeface="+mn-lt"/>
+        <a:ea typeface="+mn-ea"/>
+        <a:cs typeface="+mn-cs"/>
+      </a:defRPr>
+    </a:lvl8pPr>
+    <a:lvl9pPr marL="3657600" algn="l" defTabSz="914400" rtl="0" eaLnBrk="1" latinLnBrk="0" hangingPunct="1">
+      <a:defRPr sz="1800" kern="1200">
+        <a:solidFill>
+          <a:schemeClr val="tx1"/>
+        </a:solidFill>
+        <a:latin typeface="+mn-lt"/>
+        <a:ea typeface="+mn-ea"/>
+        <a:cs typeface="+mn-cs"/>
+      </a:defRPr>
+    </a:lvl9pPr>
   </p:defaultTextStyle>
   <p:extLst>
     <p:ext uri="{EFAFB233-063F-42B5-8137-9DF3F51BA10A}">
-      <ns3:sldGuideLst/>
+      <p15:sldGuideLst/>
     </p:ext>
   </p:extLst>
 </p:presentation>

</xml_diff>

<commit_message>
Update pitch team slide
</commit_message>
<xml_diff>
--- a/docs/hyperspace-frontier-pitch-video-deck.pptx
+++ b/docs/hyperspace-frontier-pitch-video-deck.pptx
@@ -4458,7 +4458,7 @@
                 <a:ea typeface="Inter" pitchFamily="34" charset="-122"/>
                 <a:cs typeface="Inter" pitchFamily="34" charset="-120"/>
               </a:rPr>
-              <a:t>15+ years building and scaling technical products</a:t>
+              <a:t>15+ years building products; Solana since 2022</a:t>
             </a:r>
             <a:endParaRPr lang="en-US" sz="980" dirty="0"/>
           </a:p>
@@ -4481,7 +4481,7 @@
                 <a:ea typeface="Inter" pitchFamily="34" charset="-122"/>
                 <a:cs typeface="Inter" pitchFamily="34" charset="-120"/>
               </a:rPr>
-              <a:t>Deputy CEO at Cambrian, Solana restaking devtools</a:t>
+              <a:t>Cambrian Deputy CEO, 05.2024-07.2025</a:t>
             </a:r>
             <a:endParaRPr lang="en-US" sz="980" dirty="0"/>
           </a:p>
@@ -4504,7 +4504,7 @@
                 <a:ea typeface="Inter" pitchFamily="34" charset="-122"/>
                 <a:cs typeface="Inter" pitchFamily="34" charset="-120"/>
               </a:rPr>
-              <a:t>Partnerships with Jito Labs, Solayer, Fragmetric and KyrosFi</a:t>
+              <a:t>Solana restaking devtools: pre-seed, pivot, Rust/CPO hiring</a:t>
             </a:r>
             <a:endParaRPr lang="en-US" sz="980" dirty="0"/>
           </a:p>
@@ -4527,7 +4527,7 @@
                 <a:ea typeface="Inter" pitchFamily="34" charset="-122"/>
                 <a:cs typeface="Inter" pitchFamily="34" charset="-120"/>
               </a:rPr>
-              <a:t>Solana since 2022: two Hacker Houses, Breakpoint 2024, Crossroads 2025</a:t>
+              <a:t>Jito/Solayer/Fragmetric/KyrosFi partnerships; 2 pilots</a:t>
             </a:r>
             <a:endParaRPr lang="en-US" sz="980" dirty="0"/>
           </a:p>

</xml_diff>

<commit_message>
Add demo repo QR to pitch deck
</commit_message>
<xml_diff>
--- a/docs/hyperspace-frontier-pitch-video-deck.pptx
+++ b/docs/hyperspace-frontier-pitch-video-deck.pptx
@@ -1884,7 +1884,7 @@
 </file>
 
 <file path=ppt/slides/slide11.xml><?xml version="1.0" encoding="utf-8"?>
-<p:sld xmlns:a="http://schemas.openxmlformats.org/drawingml/2006/main" xmlns:p="http://schemas.openxmlformats.org/presentationml/2006/main">
+<p:sld xmlns:a="http://schemas.openxmlformats.org/drawingml/2006/main" xmlns:p="http://schemas.openxmlformats.org/presentationml/2006/main" xmlns:r="http://schemas.openxmlformats.org/officeDocument/2006/relationships">
   <p:cSld name="Slide 11">
     <p:bg>
       <p:bgPr>
@@ -2201,6 +2201,70 @@
           </a:p>
         </p:txBody>
       </p:sp>
+      <p:sp>
+        <p:nvSpPr>
+          <p:cNvPr id="5" name="Demo repository link"/>
+          <p:cNvSpPr txBox="1"/>
+          <p:nvPr/>
+        </p:nvSpPr>
+        <p:spPr>
+          <a:xfrm>
+            <a:off x="609600" y="4430000"/>
+            <a:ext cx="6600000" cy="360000"/>
+          </a:xfrm>
+          <a:prstGeom prst="rect">
+            <a:avLst/>
+          </a:prstGeom>
+          <a:noFill/>
+          <a:ln>
+            <a:noFill/>
+          </a:ln>
+        </p:spPr>
+        <p:txBody>
+          <a:bodyPr wrap="square" lIns="0" tIns="0" rIns="0" bIns="0" anchor="t"/>
+          <a:lstStyle/>
+          <a:p>
+            <a:pPr marL="0" indent="0" algn="l">
+              <a:buNone/>
+            </a:pPr>
+            <a:r>
+              <a:rPr lang="en-US" sz="820" b="1" kern="0" dirty="0">
+                <a:solidFill>
+                  <a:srgbClr val="FFFFFF"/>
+                </a:solidFill>
+                <a:latin typeface="Inter" pitchFamily="34" charset="0"/>
+                <a:hlinkClick r:id="rId8"/>
+              </a:rPr>
+              <a:t>Demo repo: https://github.com/hyperspace-zone/hyperspace-agent-vpn-demo/tree/main</a:t>
+            </a:r>
+            <a:endParaRPr lang="en-US" sz="820" dirty="0"/>
+          </a:p>
+        </p:txBody>
+      </p:sp>
+      <p:pic>
+        <p:nvPicPr>
+          <p:cNvPr id="6" name="Demo repository QR"/>
+          <p:cNvPicPr>
+            <a:picLocks noChangeAspect="1"/>
+          </p:cNvPicPr>
+          <p:nvPr/>
+        </p:nvPicPr>
+        <p:blipFill>
+          <a:blip r:embed="rId7"/>
+          <a:stretch>
+            <a:fillRect/>
+          </a:stretch>
+        </p:blipFill>
+        <p:spPr>
+          <a:xfrm>
+            <a:off x="7700000" y="3880000"/>
+            <a:ext cx="760000" cy="760000"/>
+          </a:xfrm>
+          <a:prstGeom prst="rect">
+            <a:avLst/>
+          </a:prstGeom>
+        </p:spPr>
+      </p:pic>
     </p:spTree>
   </p:cSld>
   <p:clrMapOvr>

</xml_diff>

<commit_message>
Add SVG LON outcome metrics
</commit_message>
<xml_diff>
--- a/docs/hyperspace-frontier-pitch-video-deck.pptx
+++ b/docs/hyperspace-frontier-pitch-video-deck.pptx
@@ -2126,7 +2126,7 @@
                 <a:ea typeface="Inter" pitchFamily="34" charset="-122"/>
                 <a:cs typeface="Inter" pitchFamily="34" charset="-120"/>
               </a:rPr>
-              <a:t>Launch ask</a:t>
+              <a:t>SVG -&gt; LON outcomes</a:t>
             </a:r>
             <a:endParaRPr lang="en-US" sz="1120" dirty="0"/>
           </a:p>
@@ -2149,7 +2149,7 @@
                 <a:ea typeface="Inter" pitchFamily="34" charset="-122"/>
                 <a:cs typeface="Inter" pitchFamily="34" charset="-120"/>
               </a:rPr>
-              <a:t>Test agent-native paid connectivity</a:t>
+              <a:t>Target: 185.97.160.8:443</a:t>
             </a:r>
             <a:endParaRPr lang="en-US" sz="1060" dirty="0"/>
           </a:p>
@@ -2172,7 +2172,7 @@
                 <a:ea typeface="Inter" pitchFamily="34" charset="-122"/>
                 <a:cs typeface="Inter" pitchFamily="34" charset="-120"/>
               </a:rPr>
-              <a:t>Connect hosted agents and crawlers</a:t>
+              <a:t>p95: 98.535 -&gt; 33.007 ms</a:t>
             </a:r>
             <a:endParaRPr lang="en-US" sz="1060" dirty="0"/>
           </a:p>
@@ -2195,7 +2195,53 @@
                 <a:ea typeface="Inter" pitchFamily="34" charset="-122"/>
                 <a:cs typeface="Inter" pitchFamily="34" charset="-120"/>
               </a:rPr>
-              <a:t>Partner with Solana RPC and indexer teams</a:t>
+              <a:t>stddev jitter: 23.400 -&gt; 0.206 ms</a:t>
+            </a:r>
+            <a:endParaRPr lang="en-US" sz="1060" dirty="0"/>
+          </a:p>
+          <a:p>
+            <a:pPr marL="342900" indent="-342900" algn="l">
+              <a:lnSpc>
+                <a:spcPts val="1450"/>
+              </a:lnSpc>
+              <a:buSzPct val="100000"/>
+              <a:buChar char="•"/>
+            </a:pPr>
+            <a:r>
+              <a:rPr lang="en-US" sz="1060" kern="0" spc="0" dirty="0">
+                <a:solidFill>
+                  <a:srgbClr val="FFFFFF">
+                    <a:alpha val="99000"/>
+                  </a:srgbClr>
+                </a:solidFill>
+                <a:latin typeface="Inter" pitchFamily="34" charset="0"/>
+                <a:ea typeface="Inter" pitchFamily="34" charset="-122"/>
+                <a:cs typeface="Inter" pitchFamily="34" charset="-120"/>
+              </a:rPr>
+              <a:t>mean abs delta: 19.316 -&gt; 0.209 ms</a:t>
+            </a:r>
+            <a:endParaRPr lang="en-US" sz="1060" dirty="0"/>
+          </a:p>
+          <a:p>
+            <a:pPr marL="342900" indent="-342900" algn="l">
+              <a:lnSpc>
+                <a:spcPts val="1450"/>
+              </a:lnSpc>
+              <a:buSzPct val="100000"/>
+              <a:buChar char="•"/>
+            </a:pPr>
+            <a:r>
+              <a:rPr lang="en-US" sz="1060" kern="0" spc="0" dirty="0">
+                <a:solidFill>
+                  <a:srgbClr val="FFFFFF">
+                    <a:alpha val="99000"/>
+                  </a:srgbClr>
+                </a:solidFill>
+                <a:latin typeface="Inter" pitchFamily="34" charset="0"/>
+                <a:ea typeface="Inter" pitchFamily="34" charset="-122"/>
+                <a:cs typeface="Inter" pitchFamily="34" charset="-120"/>
+              </a:rPr>
+              <a:t>median: 29.054 -&gt; 32.599 ms</a:t>
             </a:r>
             <a:endParaRPr lang="en-US" sz="1060" dirty="0"/>
           </a:p>

</xml_diff>